<commit_message>
docs: document the real aws vpc and eks deployment in readme, submission and slides
</commit_message>
<xml_diff>
--- a/presentation.pptx
+++ b/presentation.pptx
@@ -118,19 +118,19 @@
   <p:extLst>
     <p:ext uri="{521415D9-36F7-43E2-AB2F-B90AF26B5E84}">
       <p14:sectionLst xmlns:p14="http://schemas.microsoft.com/office/powerpoint/2010/main">
-        <p14:section name="Intro" id="{d3ff0235-30a5-dcc6-ef8e-6b3e4d3d6221}">
+        <p14:section name="Intro" id="{7f73adcd-3af6-eb01-8e9d-74943d0f8b79}">
           <p14:sldIdLst>
             <p14:sldId id="256"/>
             <p14:sldId id="257"/>
           </p14:sldIdLst>
         </p14:section>
-        <p14:section name="Product" id="{3cdc79c1-50a1-81ec-306c-f97419186d99}">
+        <p14:section name="Product" id="{ef00d47a-81a5-d9e3-79c4-40611f33f8a5}">
           <p14:sldIdLst>
             <p14:sldId id="258"/>
             <p14:sldId id="259"/>
           </p14:sldIdLst>
         </p14:section>
-        <p14:section name="Platform" id="{916d7b4c-caa1-5884-5157-d07c50aa8cf4}">
+        <p14:section name="Platform" id="{a0be950a-a02c-1c1b-ce4f-07a86d5b0f73}">
           <p14:sldIdLst>
             <p14:sldId id="260"/>
             <p14:sldId id="261"/>
@@ -138,13 +138,13 @@
             <p14:sldId id="263"/>
           </p14:sldIdLst>
         </p14:section>
-        <p14:section name="Operate" id="{3bd7c58e-180a-a5ab-8a20-f63b4bd5ba54}">
+        <p14:section name="Operate" id="{7f9f7125-7ae5-c86e-9c96-b89cc2cb19f1}">
           <p14:sldIdLst>
             <p14:sldId id="264"/>
             <p14:sldId id="265"/>
           </p14:sldIdLst>
         </p14:section>
-        <p14:section name="Wrap up" id="{f98c5de4-fd26-d780-6c14-376fcf7ed4b9}">
+        <p14:section name="Wrap up" id="{ec3d7c67-9459-0d9c-6c62-8e36330ab54d}">
           <p14:sldIdLst>
             <p14:sldId id="266"/>
             <p14:sldId id="267"/>
@@ -1346,7 +1346,7 @@
           <a:p>
             <a:r>
               <a:rPr lang="en-US" dirty="0"/>
-              <a:t>Terraform describes the AWS network: a VPC with two public and two private subnets, NAT and routing, plus EKS behind a switch. LocalStack emulates AWS locally so nothing is billed, and the same code runs on real AWS by flipping one variable. Terraform also creates the kind cluster, so destroy really tears everything down.</a:t>
+              <a:t>Terraform builds a real AWS network in Sydney: a VPC with two public and two private subnets, NAT and routing, then an EKS cluster with a managed node group and the EBS CSI driver. That is 26 resources, applied, verified and destroyed to keep cost down. A second workspace runs the same code against LocalStack and kind, so day to day work is free.</a:t>
             </a:r>
             <a:endParaRPr lang="en-US" dirty="0"/>
           </a:p>
@@ -1434,7 +1434,7 @@
           <a:p>
             <a:r>
               <a:rPr lang="en-US" dirty="0"/>
-              <a:t>One Helm chart runs both environments. Migrations run once under a database lock, pods run as non-root, and the HPA scaled the backend from 2 to 6 pods during the load test.</a:t>
+              <a:t>One Helm chart runs dev and staging on kind, and staging on real Amazon EKS, where Argo CD pulled every green build and an AWS load balancer served it. Migrations run once under a database lock, pods run as non-root, and the HPA scaled the backend from 2 to 6 pods during the load test.</a:t>
             </a:r>
             <a:endParaRPr lang="en-US" dirty="0"/>
           </a:p>
@@ -8334,7 +8334,7 @@
                 <a:ea typeface="Calibri" pitchFamily="34" charset="-122"/>
                 <a:cs typeface="Calibri" pitchFamily="34" charset="-120"/>
               </a:rPr>
-              <a:t>LocalStack</a:t>
+              <a:t>AWS EKS</a:t>
             </a:r>
             <a:endParaRPr lang="en-US" sz="1200" dirty="0"/>
           </a:p>
@@ -8381,7 +8381,7 @@
                 <a:ea typeface="Calibri" pitchFamily="34" charset="-122"/>
                 <a:cs typeface="Calibri" pitchFamily="34" charset="-120"/>
               </a:rPr>
-              <a:t>kind</a:t>
+              <a:t>LocalStack</a:t>
             </a:r>
             <a:endParaRPr lang="en-US" sz="1200" dirty="0"/>
           </a:p>
@@ -8428,7 +8428,7 @@
                 <a:ea typeface="Calibri" pitchFamily="34" charset="-122"/>
                 <a:cs typeface="Calibri" pitchFamily="34" charset="-120"/>
               </a:rPr>
-              <a:t>Helm</a:t>
+              <a:t>kind</a:t>
             </a:r>
             <a:endParaRPr lang="en-US" sz="1200" dirty="0"/>
           </a:p>
@@ -8475,7 +8475,7 @@
                 <a:ea typeface="Calibri" pitchFamily="34" charset="-122"/>
                 <a:cs typeface="Calibri" pitchFamily="34" charset="-120"/>
               </a:rPr>
-              <a:t>ingress-nginx</a:t>
+              <a:t>Helm</a:t>
             </a:r>
             <a:endParaRPr lang="en-US" sz="1200" dirty="0"/>
           </a:p>
@@ -11626,7 +11626,7 @@
                   <a:srgbClr val="1B1A24"/>
                 </a:solidFill>
               </a:rPr>
-              <a:t>What one terraform apply creates</a:t>
+              <a:t>What terraform apply creates on AWS</a:t>
             </a:r>
             <a:endParaRPr lang="en-US" sz="1600" dirty="0"/>
           </a:p>
@@ -11709,7 +11709,7 @@
                   <a:srgbClr val="1B1A24"/>
                 </a:solidFill>
               </a:rPr>
-              <a:t>10.20.0.0/16 in ap-south-1</a:t>
+              <a:t>10.20.0.0/16 in ap-southeast-2</a:t>
             </a:r>
             <a:endParaRPr lang="en-US" sz="1400" dirty="0"/>
           </a:p>
@@ -11958,7 +11958,7 @@
                   <a:srgbClr val="1B1A24"/>
                 </a:solidFill>
               </a:rPr>
-              <a:t>cluster, IAM, node group (switch)</a:t>
+              <a:t>1.35, 2 x m7i-flex.large nodes</a:t>
             </a:r>
             <a:endParaRPr lang="en-US" sz="1400" dirty="0"/>
           </a:p>
@@ -12005,7 +12005,7 @@
                 <a:ea typeface="Calibri" pitchFamily="34" charset="-122"/>
                 <a:cs typeface="Calibri" pitchFamily="34" charset="-120"/>
               </a:rPr>
-              <a:t>kind</a:t>
+              <a:t>Add-ons</a:t>
             </a:r>
             <a:endParaRPr lang="en-US" sz="1200" dirty="0"/>
           </a:p>
@@ -12041,7 +12041,7 @@
                   <a:srgbClr val="1B1A24"/>
                 </a:solidFill>
               </a:rPr>
-              <a:t>3 node cluster, ports 80/443</a:t>
+              <a:t>Pod Identity, EBS CSI driver</a:t>
             </a:r>
             <a:endParaRPr lang="en-US" sz="1400" dirty="0"/>
           </a:p>
@@ -12177,7 +12177,7 @@
                 <a:ea typeface="Roboto Mono" pitchFamily="34" charset="-122"/>
                 <a:cs typeface="Roboto Mono" pitchFamily="34" charset="-120"/>
               </a:rPr>
-              <a:t>15</a:t>
+              <a:t>26</a:t>
             </a:r>
             <a:endParaRPr lang="en-US" sz="4400" dirty="0"/>
           </a:p>
@@ -12213,7 +12213,7 @@
                   <a:srgbClr val="1B1A24"/>
                 </a:solidFill>
               </a:rPr>
-              <a:t>resources applied</a:t>
+              <a:t>applied on real AWS</a:t>
             </a:r>
             <a:endParaRPr lang="en-US" sz="1400" dirty="0"/>
           </a:p>
@@ -12252,7 +12252,7 @@
                 <a:ea typeface="Roboto Mono" pitchFamily="34" charset="-122"/>
                 <a:cs typeface="Roboto Mono" pitchFamily="34" charset="-120"/>
               </a:rPr>
-              <a:t>23</a:t>
+              <a:t>15</a:t>
             </a:r>
             <a:endParaRPr lang="en-US" sz="4400" dirty="0"/>
           </a:p>
@@ -12288,7 +12288,7 @@
                   <a:srgbClr val="1B1A24"/>
                 </a:solidFill>
               </a:rPr>
-              <a:t>with EKS switched on</a:t>
+              <a:t>locally, LocalStack + kind</a:t>
             </a:r>
             <a:endParaRPr lang="en-US" sz="1400" dirty="0"/>
           </a:p>
@@ -12540,7 +12540,7 @@
                   <a:srgbClr val="6B6475"/>
                 </a:solidFill>
               </a:rPr>
-              <a:t>Runs against LocalStack by default; one variable switches it to real AWS.</a:t>
+              <a:t>Two workspaces: LocalStack + kind for free, real EKS in Sydney.</a:t>
             </a:r>
             <a:endParaRPr lang="en-US" sz="1400" dirty="0"/>
           </a:p>
@@ -12705,7 +12705,7 @@
                 <a:ea typeface="Roboto Mono" pitchFamily="34" charset="-122"/>
                 <a:cs typeface="Roboto Mono" pitchFamily="34" charset="-120"/>
               </a:rPr>
-              <a:t>two environments</a:t>
+              <a:t>kind and EKS</a:t>
             </a:r>
             <a:endParaRPr lang="en-US" sz="3200" dirty="0"/>
           </a:p>
@@ -13237,7 +13237,7 @@
       </p:sp>
       <p:pic>
         <p:nvPicPr>
-          <p:cNvPr id="21" name="Image 3" descr="dev and staging">    </p:cNvPr>
+          <p:cNvPr id="21" name="Image 3" descr="kind and EKS">    </p:cNvPr>
           <p:cNvPicPr>
             <a:picLocks noChangeAspect="1"/>
           </p:cNvPicPr>
@@ -13289,7 +13289,7 @@
                   <a:srgbClr val="1B1A24"/>
                 </a:solidFill>
               </a:rPr>
-              <a:t>dev and staging</a:t>
+              <a:t>kind and EKS</a:t>
             </a:r>
             <a:endParaRPr lang="en-US" sz="1500" dirty="0"/>
           </a:p>
@@ -13325,7 +13325,7 @@
                   <a:srgbClr val="6B6475"/>
                 </a:solidFill>
               </a:rPr>
-              <a:t>helm upgrade for dev; Argo CD syncs staging from GitHub with GHCR images.</a:t>
+              <a:t>helm upgrade for dev; Argo CD syncs staging on kind and on real EKS from Git.</a:t>
             </a:r>
             <a:endParaRPr lang="en-US" sz="1200" dirty="0"/>
           </a:p>
@@ -13592,7 +13592,7 @@
                 <a:ea typeface="Calibri" pitchFamily="34" charset="-122"/>
                 <a:cs typeface="Calibri" pitchFamily="34" charset="-120"/>
               </a:rPr>
-              <a:t>staging.fellow.localhost</a:t>
+              <a:t>EKS via AWS NLB</a:t>
             </a:r>
             <a:endParaRPr lang="en-US" sz="1100" dirty="0"/>
           </a:p>

</xml_diff>